<commit_message>
Add value-cycle diagram in voyage tone; refine dark thumbnail
Co-Authored-By: Claude Sonnet 5.5 <noreply@anthropic.com>
Claude-Session: https://claude.ai/code/session_01EAJx54yEDWUst2AHK2BTn1
</commit_message>
<xml_diff>
--- a/guruguru/guruguru_thumbnails_v3.pptx
+++ b/guruguru/guruguru_thumbnails_v3.pptx
@@ -5179,7 +5179,7 @@
             <a:avLst/>
           </a:prstGeom>
           <a:solidFill>
-            <a:srgbClr val="0A0A0A"/>
+            <a:srgbClr val="080808"/>
           </a:solidFill>
           <a:ln>
             <a:noFill/>
@@ -5201,14 +5201,14 @@
         </p:nvSpPr>
         <p:spPr>
           <a:xfrm>
-            <a:off x="4983480" y="502920"/>
-            <a:ext cx="2240280" cy="3383280"/>
+            <a:off x="5120640" y="457200"/>
+            <a:ext cx="1947672" cy="3246120"/>
           </a:xfrm>
           <a:prstGeom prst="rect">
             <a:avLst/>
           </a:prstGeom>
           <a:solidFill>
-            <a:srgbClr val="222222"/>
+            <a:srgbClr val="1C1C1C"/>
           </a:solidFill>
           <a:ln>
             <a:noFill/>
@@ -5230,8 +5230,8 @@
         </p:nvSpPr>
         <p:spPr>
           <a:xfrm>
-            <a:off x="5349240" y="502920"/>
-            <a:ext cx="1508760" cy="3383280"/>
+            <a:off x="5440680" y="457200"/>
+            <a:ext cx="1307592" cy="3246120"/>
           </a:xfrm>
           <a:prstGeom prst="rect">
             <a:avLst/>
@@ -5239,10 +5239,10 @@
           <a:gradFill rotWithShape="1">
             <a:gsLst>
               <a:gs pos="0">
-                <a:srgbClr val="FFE0B8"/>
+                <a:srgbClr val="FFE6C4"/>
               </a:gs>
               <a:gs pos="100000">
-                <a:srgbClr val="E07A3A"/>
+                <a:srgbClr val="E68442"/>
               </a:gs>
             </a:gsLst>
             <a:lin scaled="0" ang="5400000"/>
@@ -5267,8 +5267,8 @@
         </p:nvSpPr>
         <p:spPr>
           <a:xfrm>
-            <a:off x="5349240" y="2377440"/>
-            <a:ext cx="1508760" cy="1508760"/>
+            <a:off x="5440680" y="2240280"/>
+            <a:ext cx="1307592" cy="1463040"/>
           </a:xfrm>
           <a:prstGeom prst="rect">
             <a:avLst/>
@@ -5276,10 +5276,10 @@
           <a:gradFill rotWithShape="1">
             <a:gsLst>
               <a:gs pos="0">
-                <a:srgbClr val="E07A3A"/>
+                <a:srgbClr val="E68442"/>
               </a:gs>
               <a:gs pos="100000">
-                <a:srgbClr val="8A3A1A"/>
+                <a:srgbClr val="7A3214"/>
               </a:gs>
             </a:gsLst>
             <a:lin scaled="0" ang="5400000"/>
@@ -5298,14 +5298,51 @@
       </p:sp>
       <p:sp>
         <p:nvSpPr>
-          <p:cNvPr id="6" name="TextBox 5"/>
+          <p:cNvPr id="6" name="Trapezoid 5"/>
+          <p:cNvSpPr/>
+          <p:nvPr/>
+        </p:nvSpPr>
+        <p:spPr>
+          <a:xfrm>
+            <a:off x="4480560" y="3703320"/>
+            <a:ext cx="3227832" cy="548640"/>
+          </a:xfrm>
+          <a:prstGeom prst="trapezoid">
+            <a:avLst/>
+          </a:prstGeom>
+          <a:gradFill rotWithShape="1">
+            <a:gsLst>
+              <a:gs pos="0">
+                <a:srgbClr val="7A3214"/>
+              </a:gs>
+              <a:gs pos="100000">
+                <a:srgbClr val="080808"/>
+              </a:gs>
+            </a:gsLst>
+            <a:lin scaled="0" ang="5400000"/>
+          </a:gradFill>
+          <a:ln>
+            <a:noFill/>
+          </a:ln>
+        </p:spPr>
+        <p:txBody>
+          <a:bodyPr rtlCol="0" anchor="ctr"/>
+          <a:lstStyle/>
+          <a:p>
+            <a:pPr algn="ctr"/>
+          </a:p>
+        </p:txBody>
+      </p:sp>
+      <p:sp>
+        <p:nvSpPr>
+          <p:cNvPr id="7" name="TextBox 6"/>
           <p:cNvSpPr txBox="1"/>
           <p:nvPr/>
         </p:nvSpPr>
         <p:spPr>
           <a:xfrm>
-            <a:off x="457200" y="4206240"/>
-            <a:ext cx="11247120" cy="1097280"/>
+            <a:off x="548640" y="502920"/>
+            <a:ext cx="4572000" cy="274320"/>
           </a:xfrm>
           <a:prstGeom prst="rect">
             <a:avLst/>
@@ -5318,9 +5355,79 @@
           </a:bodyPr>
           <a:lstStyle/>
           <a:p>
-            <a:pPr algn="ctr"/>
-            <a:r>
-              <a:rPr sz="6400" b="1" spc="300">
+            <a:pPr algn="l"/>
+            <a:r>
+              <a:rPr sz="1100" b="0" spc="400">
+                <a:solidFill>
+                  <a:srgbClr val="999999"/>
+                </a:solidFill>
+                <a:latin typeface="Yu Gothic"/>
+              </a:rPr>
+              <a:t>COPPER CYCLE INTERNSHIP</a:t>
+            </a:r>
+          </a:p>
+        </p:txBody>
+      </p:sp>
+      <p:sp>
+        <p:nvSpPr>
+          <p:cNvPr id="8" name="TextBox 7"/>
+          <p:cNvSpPr txBox="1"/>
+          <p:nvPr/>
+        </p:nvSpPr>
+        <p:spPr>
+          <a:xfrm>
+            <a:off x="7315200" y="502920"/>
+            <a:ext cx="4297680" cy="274320"/>
+          </a:xfrm>
+          <a:prstGeom prst="rect">
+            <a:avLst/>
+          </a:prstGeom>
+          <a:noFill/>
+        </p:spPr>
+        <p:txBody>
+          <a:bodyPr wrap="square" anchor="ctr" lIns="0" rIns="0" tIns="0" bIns="0">
+            <a:spAutoFit/>
+          </a:bodyPr>
+          <a:lstStyle/>
+          <a:p>
+            <a:pPr algn="r"/>
+            <a:r>
+              <a:rPr sz="1300" b="0" spc="200">
+                <a:solidFill>
+                  <a:srgbClr val="AAAAAA"/>
+                </a:solidFill>
+                <a:latin typeface="Yu Mincho"/>
+              </a:rPr>
+              <a:t>銅のめぐりを、経営する。</a:t>
+            </a:r>
+          </a:p>
+        </p:txBody>
+      </p:sp>
+      <p:sp>
+        <p:nvSpPr>
+          <p:cNvPr id="9" name="TextBox 8"/>
+          <p:cNvSpPr txBox="1"/>
+          <p:nvPr/>
+        </p:nvSpPr>
+        <p:spPr>
+          <a:xfrm>
+            <a:off x="457200" y="4343400"/>
+            <a:ext cx="11247120" cy="1005840"/>
+          </a:xfrm>
+          <a:prstGeom prst="rect">
+            <a:avLst/>
+          </a:prstGeom>
+          <a:noFill/>
+        </p:spPr>
+        <p:txBody>
+          <a:bodyPr wrap="square" anchor="ctr" lIns="0" rIns="0" tIns="0" bIns="0">
+            <a:spAutoFit/>
+          </a:bodyPr>
+          <a:lstStyle/>
+          <a:p>
+            <a:pPr algn="ctr"/>
+            <a:r>
+              <a:rPr sz="6000" b="1" spc="400">
                 <a:solidFill>
                   <a:srgbClr val="FFFFFF"/>
                 </a:solidFill>
@@ -5333,14 +5440,14 @@
       </p:sp>
       <p:sp>
         <p:nvSpPr>
-          <p:cNvPr id="7" name="TextBox 6"/>
+          <p:cNvPr id="10" name="TextBox 9"/>
           <p:cNvSpPr txBox="1"/>
           <p:nvPr/>
         </p:nvSpPr>
         <p:spPr>
           <a:xfrm>
-            <a:off x="457200" y="5303520"/>
-            <a:ext cx="11247120" cy="548640"/>
+            <a:off x="457200" y="5532120"/>
+            <a:ext cx="11247120" cy="457200"/>
           </a:xfrm>
           <a:prstGeom prst="rect">
             <a:avLst/>
@@ -5355,7 +5462,7 @@
           <a:p>
             <a:pPr algn="ctr"/>
             <a:r>
-              <a:rPr sz="2600" b="0" spc="300">
+              <a:rPr sz="2200" b="0" spc="500">
                 <a:solidFill>
                   <a:srgbClr val="DDDDDD"/>
                 </a:solidFill>
@@ -5368,14 +5475,14 @@
       </p:sp>
       <p:sp>
         <p:nvSpPr>
-          <p:cNvPr id="8" name="TextBox 7"/>
+          <p:cNvPr id="11" name="TextBox 10"/>
           <p:cNvSpPr txBox="1"/>
           <p:nvPr/>
         </p:nvSpPr>
         <p:spPr>
           <a:xfrm>
-            <a:off x="457200" y="6172200"/>
-            <a:ext cx="11247120" cy="365760"/>
+            <a:off x="457200" y="6263640"/>
+            <a:ext cx="11247120" cy="274320"/>
           </a:xfrm>
           <a:prstGeom prst="rect">
             <a:avLst/>
@@ -5390,48 +5497,13 @@
           <a:p>
             <a:pPr algn="ctr"/>
             <a:r>
-              <a:rPr sz="1400" b="0">
+              <a:rPr sz="1200" b="0" spc="150">
                 <a:solidFill>
-                  <a:srgbClr val="AAAAAA"/>
+                  <a:srgbClr val="999999"/>
                 </a:solidFill>
                 <a:latin typeface="Yu Gothic"/>
               </a:rPr>
-              <a:t>銅めぐりインターンシップ（仮）｜28卒向け｜12月〜1月</a:t>
-            </a:r>
-          </a:p>
-        </p:txBody>
-      </p:sp>
-      <p:sp>
-        <p:nvSpPr>
-          <p:cNvPr id="9" name="TextBox 8"/>
-          <p:cNvSpPr txBox="1"/>
-          <p:nvPr/>
-        </p:nvSpPr>
-        <p:spPr>
-          <a:xfrm>
-            <a:off x="7863840" y="640080"/>
-            <a:ext cx="3931920" cy="365760"/>
-          </a:xfrm>
-          <a:prstGeom prst="rect">
-            <a:avLst/>
-          </a:prstGeom>
-          <a:noFill/>
-        </p:spPr>
-        <p:txBody>
-          <a:bodyPr wrap="square" anchor="ctr" lIns="0" rIns="0" tIns="0" bIns="0">
-            <a:spAutoFit/>
-          </a:bodyPr>
-          <a:lstStyle/>
-          <a:p>
-            <a:pPr algn="r"/>
-            <a:r>
-              <a:rPr sz="1400" b="0">
-                <a:solidFill>
-                  <a:srgbClr val="AAAAAA"/>
-                </a:solidFill>
-                <a:latin typeface="Yu Mincho"/>
-              </a:rPr>
-              <a:t>――銅のめぐりを、経営する。</a:t>
+              <a:t>銅めぐりインターンシップ（仮）　28卒向け　12月〜1月</a:t>
             </a:r>
           </a:p>
         </p:txBody>

</xml_diff>